<commit_message>
Add speaker script and put it into the deck's speaker notes
~2,450-word script (~21 min), split Speaker 1 (slides 1-7) / Speaker 2 (8-16).

Co-Authored-By: Claude Opus 5.5 <noreply@anthropic.com>
Claude-Session: https://claude.ai/code/session_01DE7YBAkGkSfHn5JtJvBExm
</commit_message>
<xml_diff>
--- a/presentations/mica-seminar/MiCA_Crypto_Regulation_Seminar.pptx
+++ b/presentations/mica-seminar/MiCA_Crypto_Regulation_Seminar.pptx
@@ -1518,10 +1518,14 @@
           <a:lstStyle/>
           <a:p>
             <a:r>
-              <a:rPr lang="en-US" dirty="0"/>
-              <a:t>Speaker 1 (slides 1-7, ~10 min). Photo circles: right-click a circle &gt; Format Shape &gt; Fill &gt; Picture fill to insert a portrait.</a:t>
-            </a:r>
-            <a:endParaRPr lang="en-US" dirty="0"/>
+              <a:t>Title (Speaker 1, ~0:40)</a:t>
+            </a:r>
+          </a:p>
+          <a:p/>
+          <a:p>
+            <a:r>
+              <a:t>Good morning, everyone. My name is ___, and this is my colleague ___. Today we want to answer one question: can Europe regulate crypto without killing innovation? To answer it, we look at MiCA — the Markets in Crypto-Assets Regulation. It is the EU's rulebook for crypto, and 2026 is the year it really started to apply: since the first of July, only licensed firms may offer crypto services in the EU. So this is a good moment to look back and ask: did MiCA make the market safer, and what did it cost?</a:t>
+            </a:r>
           </a:p>
         </p:txBody>
       </p:sp>
@@ -1606,10 +1610,32 @@
           <a:lstStyle/>
           <a:p>
             <a:r>
-              <a:rPr lang="en-US" dirty="0"/>
-              <a:t/>
-            </a:r>
-            <a:endParaRPr lang="en-US" dirty="0"/>
+              <a:t>Fraud, AML &amp; KYC: the price of trust (Speaker 2, ~1:30)</a:t>
+            </a:r>
+          </a:p>
+          <a:p/>
+          <a:p>
+            <a:r>
+              <a:t>Now an area where both sides partly agree: fraud, money laundering and KYC.</a:t>
+            </a:r>
+          </a:p>
+          <a:p/>
+          <a:p>
+            <a:r>
+              <a:t>The problem is clear: crypto has been used for scams, hacks, money laundering and sanctions evasion. The EU's response has four main elements.</a:t>
+            </a:r>
+          </a:p>
+          <a:p/>
+          <a:p>
+            <a:r>
+              <a:t>First, KYC — "know your customer": platforms must check who their customers are. Second, the Travel Rule: information about the sender and the receiver must travel with every crypto transfer, similar to bank transfers. Third, AMLA, the new EU Anti-Money Laundering Authority. And fourth, DAC8, which requires platforms to report users' crypto data to tax authorities.</a:t>
+            </a:r>
+          </a:p>
+          <a:p/>
+          <a:p>
+            <a:r>
+              <a:t>How you see these rules depends on your perspective. From a pro-innovation view, a clean market attracts institutional capital: banks and investment funds only enter markets they trust. From an anti-innovation view, compliance costs favour big players: a small startup struggles to pay for lawyers, audits and IT systems, while a big exchange can easily afford them. So trust has a price — and that price is not the same for everyone.</a:t>
+            </a:r>
           </a:p>
         </p:txBody>
       </p:sp>
@@ -1694,10 +1720,44 @@
           <a:lstStyle/>
           <a:p>
             <a:r>
-              <a:rPr lang="en-US" dirty="0"/>
-              <a:t/>
-            </a:r>
-            <a:endParaRPr lang="en-US" dirty="0"/>
+              <a:t>EU vs US (Speaker 2, ~1:30)</a:t>
+            </a:r>
+          </a:p>
+          <a:p/>
+          <a:p>
+            <a:r>
+              <a:t>How does Europe's approach compare with the United States? In 2025, the US adopted the GENIUS Act.</a:t>
+            </a:r>
+          </a:p>
+          <a:p/>
+          <a:p>
+            <a:r>
+              <a:t>The first difference is scope. MiCA covers the whole crypto market, while the GENIUS Act covers only payment stablecoins.</a:t>
+            </a:r>
+          </a:p>
+          <a:p/>
+          <a:p>
+            <a:r>
+              <a:t>The second difference is philosophy. The EU wants to contain risk. The US wants to accelerate growth and support the role of the dollar.</a:t>
+            </a:r>
+          </a:p>
+          <a:p/>
+          <a:p>
+            <a:r>
+              <a:t>You can see this clearly with USDT: in Europe it is already delisted on licensed platforms, while in the US there is a transition until around 2028.</a:t>
+            </a:r>
+          </a:p>
+          <a:p/>
+          <a:p>
+            <a:r>
+              <a:t>On one point they agree: both ban paying interest to stablecoin holders.</a:t>
+            </a:r>
+          </a:p>
+          <a:p/>
+          <a:p>
+            <a:r>
+              <a:t>But the goals are different. The EU wants to limit risk inside its own market, while the US wants dollar stablecoins to grow worldwide. So our bottom line is: Europe gets compliant but smaller issuers, while the US is building global dollar champions.</a:t>
+            </a:r>
           </a:p>
         </p:txBody>
       </p:sp>
@@ -1782,10 +1842,32 @@
           <a:lstStyle/>
           <a:p>
             <a:r>
-              <a:rPr lang="en-US" dirty="0"/>
-              <a:t/>
-            </a:r>
-            <a:endParaRPr lang="en-US" dirty="0"/>
+              <a:t>The EU is adjusting: "MiCA 2" (Speaker 2, ~1:15)</a:t>
+            </a:r>
+          </a:p>
+          <a:p/>
+          <a:p>
+            <a:r>
+              <a:t>The EU is aware of these problems and is already adjusting. This process is often called "MiCA 2".</a:t>
+            </a:r>
+          </a:p>
+          <a:p/>
+          <a:p>
+            <a:r>
+              <a:t>In May 2026, the European Commission opened a consultation on the review of MiCA. It looks at topics that MiCA left open or that businesses say limit growth: DeFi, staking, lending, the interest ban and the reserve rules for stablecoins.</a:t>
+            </a:r>
+          </a:p>
+          <a:p/>
+          <a:p>
+            <a:r>
+              <a:t>The Commission has to deliver its report by the 30th of June 2027, and this report may come with a new legislative proposal.</a:t>
+            </a:r>
+          </a:p>
+          <a:p/>
+          <a:p>
+            <a:r>
+              <a:t>In parallel, there is a proposal to let ESMA — the European Securities and Markets Authority — directly supervise the largest crypto firms. Today, national authorities do this, so standards can differ from country to country. Central supervision would make the rules more uniform, but it would also move more power to the EU level.</a:t>
+            </a:r>
           </a:p>
         </p:txBody>
       </p:sp>
@@ -1870,10 +1952,38 @@
           <a:lstStyle/>
           <a:p>
             <a:r>
-              <a:rPr lang="en-US" dirty="0"/>
-              <a:t/>
-            </a:r>
-            <a:endParaRPr lang="en-US" dirty="0"/>
+              <a:t>Verdict (Speaker 2, ~1:15)</a:t>
+            </a:r>
+          </a:p>
+          <a:p/>
+          <a:p>
+            <a:r>
+              <a:t>So what is our verdict? We would summarise it like this: MiCA doesn't kill innovation — it filters it.</a:t>
+            </a:r>
+          </a:p>
+          <a:p/>
+          <a:p>
+            <a:r>
+              <a:t>The winners are firms with scale, which can afford compliance costs; institutions, which trust a regulated market; and late-stage capital — remember the 14 to 17 percent increase in funding.</a:t>
+            </a:r>
+          </a:p>
+          <a:p/>
+          <a:p>
+            <a:r>
+              <a:t>The losers are startups, for whom licence costs are high and fixed; early-stage projects, which received no extra funding; and offshore players, which are now cut off from EU users.</a:t>
+            </a:r>
+          </a:p>
+          <a:p/>
+          <a:p>
+            <a:r>
+              <a:t>The biggest risk ahead is how MiCA 2 treats DeFi. If the rules are too strict, DeFi could move out of Europe. If they are too loose, users stay unprotected.</a:t>
+            </a:r>
+          </a:p>
+          <a:p/>
+          <a:p>
+            <a:r>
+              <a:t>In short: Europe chose trust over speed.</a:t>
+            </a:r>
           </a:p>
         </p:txBody>
       </p:sp>
@@ -1958,10 +2068,44 @@
           <a:lstStyle/>
           <a:p>
             <a:r>
-              <a:rPr lang="en-US" dirty="0"/>
-              <a:t/>
-            </a:r>
-            <a:endParaRPr lang="en-US" dirty="0"/>
+              <a:t>What this means for business (Speaker 2, ~1:00)</a:t>
+            </a:r>
+          </a:p>
+          <a:p/>
+          <a:p>
+            <a:r>
+              <a:t>What does this mean in practice for a business? It depends on what you want to do.</a:t>
+            </a:r>
+          </a:p>
+          <a:p/>
+          <a:p>
+            <a:r>
+              <a:t>If you run a crypto service, like an exchange, plan a licence process of 6 to 12 months and choose your hub country carefully — one licence covers the whole EEA.</a:t>
+            </a:r>
+          </a:p>
+          <a:p/>
+          <a:p>
+            <a:r>
+              <a:t>If you want to issue a stablecoin, you need a bank or e-money licence and full reserves, and you may not pay interest to holders.</a:t>
+            </a:r>
+          </a:p>
+          <a:p/>
+          <a:p>
+            <a:r>
+              <a:t>If you build a DeFi project, you are not covered yet, but you should follow the MiCA 2 process now, because new rules may follow the 2027 report.</a:t>
+            </a:r>
+          </a:p>
+          <a:p/>
+          <a:p>
+            <a:r>
+              <a:t>And if you operate in both the EU and the US, you need two separate compliance tracks: MiCA in Europe and the GENIUS Act for US stablecoins.</a:t>
+            </a:r>
+          </a:p>
+          <a:p/>
+          <a:p>
+            <a:r>
+              <a:t>The general lesson: compliance is now part of the business model, not an afterthought.</a:t>
+            </a:r>
           </a:p>
         </p:txBody>
       </p:sp>
@@ -2046,10 +2190,26 @@
           <a:lstStyle/>
           <a:p>
             <a:r>
-              <a:rPr lang="en-US" dirty="0"/>
-              <a:t/>
-            </a:r>
-            <a:endParaRPr lang="en-US" dirty="0"/>
+              <a:t>Conclusion &amp; discussion (Speaker 2, ~1:00)</a:t>
+            </a:r>
+          </a:p>
+          <a:p/>
+          <a:p>
+            <a:r>
+              <a:t>To conclude: MiCA is the world's first comprehensive crypto regime — one rulebook for 27 countries. 2026 is the enforcement year: only licensed firms may operate. And there is a clear trade-off: more trust and more big players, but fewer small firms and less money for early-stage projects.</a:t>
+            </a:r>
+          </a:p>
+          <a:p/>
+          <a:p>
+            <a:r>
+              <a:t>So, can Europe regulate crypto without killing innovation? Our answer is: yes — but only for those who can afford compliance.</a:t>
+            </a:r>
+          </a:p>
+          <a:p/>
+          <a:p>
+            <a:r>
+              <a:t>Now we would like to hear your opinion. Imagine you want to buy crypto: would you choose a MiCA-licensed exchange, or a cheaper offshore one? And why?</a:t>
+            </a:r>
           </a:p>
         </p:txBody>
       </p:sp>
@@ -2134,10 +2294,14 @@
           <a:lstStyle/>
           <a:p>
             <a:r>
-              <a:rPr lang="en-US" dirty="0"/>
-              <a:t/>
-            </a:r>
-            <a:endParaRPr lang="en-US" dirty="0"/>
+              <a:t>Bibliography (Speaker 2, ~0:10)</a:t>
+            </a:r>
+          </a:p>
+          <a:p/>
+          <a:p>
+            <a:r>
+              <a:t>Here you can see all our sources. Thank you for your attention — we are happy to answer your questions.</a:t>
+            </a:r>
           </a:p>
         </p:txBody>
       </p:sp>
@@ -2222,10 +2386,14 @@
           <a:lstStyle/>
           <a:p>
             <a:r>
-              <a:rPr lang="en-US" dirty="0"/>
-              <a:t/>
-            </a:r>
-            <a:endParaRPr lang="en-US" dirty="0"/>
+              <a:t>Agenda (Speaker 1, ~0:40)</a:t>
+            </a:r>
+          </a:p>
+          <a:p/>
+          <a:p>
+            <a:r>
+              <a:t>Our presentation has six parts. First, we explain why crypto needs regulation at all. Second, how MiCA works — the token types, the licences and the timeline. Third, the main part: the arguments for and against MiCA. Then we compare the EU with the United States, which chose a very different approach. After that, we show how the EU is already adjusting the rules — the so-called "MiCA 2". Finally, we give our verdict and explain what all this means for businesses. At the end, we have a question for discussion.</a:t>
+            </a:r>
           </a:p>
         </p:txBody>
       </p:sp>
@@ -2310,10 +2478,44 @@
           <a:lstStyle/>
           <a:p>
             <a:r>
-              <a:rPr lang="en-US" dirty="0"/>
-              <a:t>$2.2 bn (2024) and $9.3 bn (2024) measure different things: hacks of crypto services worldwide vs. fraud losses reported by US victims to the FBI. Illicit volume is &lt;1% of all crypto activity (Chainalysis).</a:t>
-            </a:r>
-            <a:endParaRPr lang="en-US" dirty="0"/>
+              <a:t>Why crypto should be regulated? (Speaker 1, ~1:45)</a:t>
+            </a:r>
+          </a:p>
+          <a:p/>
+          <a:p>
+            <a:r>
+              <a:t>Let's start with the basic question: why should crypto be regulated at all? Crypto is growing fast, but its users face three different kinds of risk.</a:t>
+            </a:r>
+          </a:p>
+          <a:p/>
+          <a:p>
+            <a:r>
+              <a:t>The first risk is hacks. The chart shows crypto stolen from exchanges and platforms worldwide, according to Chainalysis. In 2022 it was 3.7 billion dollars. It went down to 1.8 billion in 2023, but then went up again — 2.2 billion in 2024 and 3.4 billion in 2025. So this problem does not disappear by itself.</a:t>
+            </a:r>
+          </a:p>
+          <a:p/>
+          <a:p>
+            <a:r>
+              <a:t>The second risk is scams. Here we use data from the FBI: people in the US lost 9.3 billion dollars to crypto fraud in 2024, mostly through fake investment schemes. That is 66 percent more than a year before.</a:t>
+            </a:r>
+          </a:p>
+          <a:p/>
+          <a:p>
+            <a:r>
+              <a:t>The third risk is crime more broadly. In 2025, criminal and sanctioned addresses received 154 billion dollars in crypto — a record. To be fair, this is still less than one percent of all crypto activity, so most crypto use is legal.</a:t>
+            </a:r>
+          </a:p>
+          <a:p/>
+          <a:p>
+            <a:r>
+              <a:t>Please note that these numbers measure different things, which is why they don't match: hacks are theft from platforms, scams are money tricked out of individuals, and crime is all money going to illicit addresses.</a:t>
+            </a:r>
+          </a:p>
+          <a:p/>
+          <a:p>
+            <a:r>
+              <a:t>And more and more people are exposed to these risks: according to the ECB, crypto ownership in the euro area rose from 4 percent in 2022 to 9 percent in 2024.</a:t>
+            </a:r>
           </a:p>
         </p:txBody>
       </p:sp>
@@ -2398,10 +2600,32 @@
           <a:lstStyle/>
           <a:p>
             <a:r>
-              <a:rPr lang="en-US" dirty="0"/>
-              <a:t/>
-            </a:r>
-            <a:endParaRPr lang="en-US" dirty="0"/>
+              <a:t>The problem MiCA was built to solve (Speaker 1, ~1:30)</a:t>
+            </a:r>
+          </a:p>
+          <a:p/>
+          <a:p>
+            <a:r>
+              <a:t>So the risks are real. But what exactly pushed the EU to act? Two things.</a:t>
+            </a:r>
+          </a:p>
+          <a:p/>
+          <a:p>
+            <a:r>
+              <a:t>First, 2022. In May, the Terra/Luna stablecoin system collapsed, and in November FTX — at that time one of the biggest crypto exchanges in the world — went bankrupt. Retail investors lost billions, and there was no common European rulebook to protect them.</a:t>
+            </a:r>
+          </a:p>
+          <a:p/>
+          <a:p>
+            <a:r>
+              <a:t>Second, fragmentation. Before MiCA, there were 27 national regimes. Every country had its own rules, and there was no EU-wide licence. A company that wanted to work across Europe needed separate approvals in each market, and the level of protection for users depended on where they lived.</a:t>
+            </a:r>
+          </a:p>
+          <a:p/>
+          <a:p>
+            <a:r>
+              <a:t>This leads to the core dilemma of our presentation. On one side, there is consumer protection and financial stability. On the other side, there is innovation and competitiveness. If the rules are too weak, people lose money. If they are too strict, companies move to other regions. MiCA tries to do both: protect people without pushing crypto businesses out of Europe. The rest of our presentation asks whether it succeeded.</a:t>
+            </a:r>
           </a:p>
         </p:txBody>
       </p:sp>
@@ -2486,10 +2710,44 @@
           <a:lstStyle/>
           <a:p>
             <a:r>
-              <a:rPr lang="en-US" dirty="0"/>
-              <a:t/>
-            </a:r>
-            <a:endParaRPr lang="en-US" dirty="0"/>
+              <a:t>MiCA in one slide (Speaker 1, ~1:45)</a:t>
+            </a:r>
+          </a:p>
+          <a:p/>
+          <a:p>
+            <a:r>
+              <a:t>So how does MiCA work? The short version: it is one rulebook for all 27 EU countries, and it does two things — it sorts tokens into three types, and it licenses the companies that offer crypto services.</a:t>
+            </a:r>
+          </a:p>
+          <a:p/>
+          <a:p>
+            <a:r>
+              <a:t>The first type is e-money tokens, or EMTs. These are stablecoins linked to one official currency — for example USDC, linked to the dollar, or EURC, linked to the euro.</a:t>
+            </a:r>
+          </a:p>
+          <a:p/>
+          <a:p>
+            <a:r>
+              <a:t>The second type is asset-referenced tokens, or ARTs. Their value is linked to a basket of assets, for example several currencies or commodities.</a:t>
+            </a:r>
+          </a:p>
+          <a:p/>
+          <a:p>
+            <a:r>
+              <a:t>The third group is everything else — for example Bitcoin or Ether. Here MiCA mainly requires a white paper: a document that explains the project and its risks to investors.</a:t>
+            </a:r>
+          </a:p>
+          <a:p/>
+          <a:p>
+            <a:r>
+              <a:t>Below the tokens you see the CASPs — crypto-asset service providers. These are exchanges, brokers and custody wallets, and they need a licence. The big advantage is the so-called "passport": a licence from one country is valid in the whole European Economic Area.</a:t>
+            </a:r>
+          </a:p>
+          <a:p/>
+          <a:p>
+            <a:r>
+              <a:t>Finally, some things are out of scope: fully decentralised finance, or DeFi, and most NFTs. They are not banned, but MiCA does not cover them — at least for now. Please keep DeFi in mind, because it will come back later.</a:t>
+            </a:r>
           </a:p>
         </p:txBody>
       </p:sp>
@@ -2574,10 +2832,26 @@
           <a:lstStyle/>
           <a:p>
             <a:r>
-              <a:rPr lang="en-US" dirty="0"/>
-              <a:t>Hungary ended its transition a year early (30 June 2025); EU-wide the transition ended on 1 July 2026.</a:t>
-            </a:r>
-            <a:endParaRPr lang="en-US" dirty="0"/>
+              <a:t>From adoption to full enforcement (Speaker 1, ~1:15)</a:t>
+            </a:r>
+          </a:p>
+          <a:p/>
+          <a:p>
+            <a:r>
+              <a:t>MiCA did not start overnight. It was adopted in 2023. The rules for stablecoins — EMTs and ARTs — started to apply in June 2024. Six months later, in December 2024, the rules for service providers followed, so exchanges and brokers could apply for licences.</a:t>
+            </a:r>
+          </a:p>
+          <a:p/>
+          <a:p>
+            <a:r>
+              <a:t>Firms that were already active under national rules got a transition period: they could keep operating while they applied for a MiCA licence. Countries could make this period shorter. Hungary, for example, chose a shortened transition, which ended on the 30th of June 2025.</a:t>
+            </a:r>
+          </a:p>
+          <a:p/>
+          <a:p>
+            <a:r>
+              <a:t>The final deadline for the whole EU was the 1st of July 2026. Since that day, the grace period is over everywhere, and only licensed firms may operate. That is why we call 2026 the enforcement year — the moment when MiCA became real for the whole market.</a:t>
+            </a:r>
           </a:p>
         </p:txBody>
       </p:sp>
@@ -2662,10 +2936,50 @@
           <a:lstStyle/>
           <a:p>
             <a:r>
-              <a:rPr lang="en-US" dirty="0"/>
-              <a:t/>
-            </a:r>
-            <a:endParaRPr lang="en-US" dirty="0"/>
+              <a:t>FOR: MiCA builds trust and attracts capital (Speaker 1, ~1:45)</a:t>
+            </a:r>
+          </a:p>
+          <a:p/>
+          <a:p>
+            <a:r>
+              <a:t>Now to the main part: the arguments for and against. Let's start with the arguments for MiCA.</a:t>
+            </a:r>
+          </a:p>
+          <a:p/>
+          <a:p>
+            <a:r>
+              <a:t>First, the passport. One licence gives access to the whole EEA — that is 30 countries. Compared with 27 different national regimes, this is a huge simplification.</a:t>
+            </a:r>
+          </a:p>
+          <a:p/>
+          <a:p>
+            <a:r>
+              <a:t>Second, traditional banks are entering the market. For example, Société Générale, through its crypto unit FORGE, issues stablecoins under MiCA. Banks only do this when the rules are clear.</a:t>
+            </a:r>
+          </a:p>
+          <a:p/>
+          <a:p>
+            <a:r>
+              <a:t>Third, clear rules build trust: users and investors know who is supervised and which rules apply.</a:t>
+            </a:r>
+          </a:p>
+          <a:p/>
+          <a:p>
+            <a:r>
+              <a:t>We can also see this in the data. A 2026 study from NOVA SBE found that after MiCA, venture capital funding for crypto startups grew by 7 to 9 percent per quarter. But look at the details: for late-stage startups, funding increased by 14 to 17 percent, while for early-stage startups there was no change. So the extra money goes mainly to bigger, more established firms — please remember this point.</a:t>
+            </a:r>
+          </a:p>
+          <a:p/>
+          <a:p>
+            <a:r>
+              <a:t>The chart on the right shows another example. EURC, Circle's MiCA-compliant euro stablecoin, increased its share of the euro stablecoin market from 17 percent to around 41 percent in just one year. So compliance can actually be a competitive advantage.</a:t>
+            </a:r>
+          </a:p>
+          <a:p/>
+          <a:p>
+            <a:r>
+              <a:t>But there is another side to this story — and my colleague will now present it.</a:t>
+            </a:r>
           </a:p>
         </p:txBody>
       </p:sp>
@@ -2750,10 +3064,38 @@
           <a:lstStyle/>
           <a:p>
             <a:r>
-              <a:rPr lang="en-US" dirty="0"/>
-              <a:t/>
-            </a:r>
-            <a:endParaRPr lang="en-US" dirty="0"/>
+              <a:t>AGAINST: The market shrank and concentrated (Speaker 2, ~1:45)</a:t>
+            </a:r>
+          </a:p>
+          <a:p/>
+          <a:p>
+            <a:r>
+              <a:t>Thank you. Now let's look at the arguments against MiCA, starting with the market itself. Our main message here: the market shrank and became more concentrated.</a:t>
+            </a:r>
+          </a:p>
+          <a:p/>
+          <a:p>
+            <a:r>
+              <a:t>Before MiCA, more than 1,200 firms were registered under national rules. By the end of the transition period, only about 210 of them had a MiCA licence — around 17 percent.</a:t>
+            </a:r>
+          </a:p>
+          <a:p/>
+          <a:p>
+            <a:r>
+              <a:t>Some industry voices are even more pessimistic. The CEO of OKX Europe said that up to 80 percent of firms may leave the EU. And according to Coincub, crypto venture capital in the EU is down 70 percent compared with the 2022 peak. Coincub is an industry source, and part of this drop is the general crypto market cycle, so we should read this number carefully.</a:t>
+            </a:r>
+          </a:p>
+          <a:p/>
+          <a:p>
+            <a:r>
+              <a:t>The chart shows where licensed firms are based. The number of licences is still growing — by the end of September 2026, there were around 360 — but they are very concentrated: Germany alone has about 95, followed by France, the Netherlands, Cyprus and Malta.</a:t>
+            </a:r>
+          </a:p>
+          <a:p/>
+          <a:p>
+            <a:r>
+              <a:t>The big international players chose specific hub countries: Binance went to France, Kraken and Coinbase to Ireland, and OKX to Malta. Because of the passport, one licence is enough, so companies choose the country where they expect the best process — and licences cluster in a few places.</a:t>
+            </a:r>
           </a:p>
         </p:txBody>
       </p:sp>
@@ -2838,10 +3180,44 @@
           <a:lstStyle/>
           <a:p>
             <a:r>
-              <a:rPr lang="en-US" dirty="0"/>
-              <a:t/>
-            </a:r>
-            <a:endParaRPr lang="en-US" dirty="0"/>
+              <a:t>AGAINST: Stablecoins and DeFi (Speaker 2, ~1:30)</a:t>
+            </a:r>
+          </a:p>
+          <a:p/>
+          <a:p>
+            <a:r>
+              <a:t>The second problem area is stablecoins and DeFi.</a:t>
+            </a:r>
+          </a:p>
+          <a:p/>
+          <a:p>
+            <a:r>
+              <a:t>First, USDT. Tether, the issuer of the largest stablecoin, did not apply for a MiCA licence. As a result, since the 1st of July 2026 there are no USDT trading pairs on licensed exchanges in the EEA.</a:t>
+            </a:r>
+          </a:p>
+          <a:p/>
+          <a:p>
+            <a:r>
+              <a:t>Second, ARTs: so far, not a single asset-referenced token has been licensed. This whole category is practically empty.</a:t>
+            </a:r>
+          </a:p>
+          <a:p/>
+          <a:p>
+            <a:r>
+              <a:t>Third, the interest ban: holders of stablecoins cannot earn interest. This may make euro stablecoins less attractive.</a:t>
+            </a:r>
+          </a:p>
+          <a:p/>
+          <a:p>
+            <a:r>
+              <a:t>And fourth, DeFi — probably the most innovative part of crypto — sits outside MiCA. It is not banned, but not regulated either, which creates legal uncertainty for anyone who wants to build it in Europe.</a:t>
+            </a:r>
+          </a:p>
+          <a:p/>
+          <a:p>
+            <a:r>
+              <a:t>The chart on the right puts this in perspective: euro stablecoins are only about 0.3 percent of the global stablecoin market — less than one billion dollars out of more than 300 billion. The stablecoin world is dominated by the dollar.</a:t>
+            </a:r>
           </a:p>
         </p:txBody>
       </p:sp>

</xml_diff>